<commit_message>
Added notes to the pptx
</commit_message>
<xml_diff>
--- a/lightning_talk_v3.pptx
+++ b/lightning_talk_v3.pptx
@@ -836,31 +836,7 @@
                 <a:ea typeface="+mn-ea"/>
                 <a:cs typeface="+mn-cs"/>
               </a:rPr>
-              <a:t>Hi, this is a reproducibility study of SAGA from the 2014 </a:t>
-            </a:r>
-            <a:r>
-              <a:rPr lang="en-US" sz="1200" kern="1200" dirty="0" err="1">
-                <a:solidFill>
-                  <a:schemeClr val="tx1"/>
-                </a:solidFill>
-                <a:effectLst/>
-                <a:latin typeface="+mn-lt"/>
-                <a:ea typeface="+mn-ea"/>
-                <a:cs typeface="+mn-cs"/>
-              </a:rPr>
-              <a:t>NeurIPS</a:t>
-            </a:r>
-            <a:r>
-              <a:rPr lang="en-US" sz="1200" kern="1200" dirty="0">
-                <a:solidFill>
-                  <a:schemeClr val="tx1"/>
-                </a:solidFill>
-                <a:effectLst/>
-                <a:latin typeface="+mn-lt"/>
-                <a:ea typeface="+mn-ea"/>
-                <a:cs typeface="+mn-cs"/>
-              </a:rPr>
-              <a:t> paper.</a:t>
+              <a:t>Hi, this is a reproducibility study of SAGA.</a:t>
             </a:r>
           </a:p>
           <a:p>
@@ -1993,9 +1969,6 @@
               </a:rPr>
               <a:t>And third, the stability benefits of variance reduction show up very clearly across random seeds.</a:t>
             </a:r>
-          </a:p>
-          <a:p>
-            <a:endParaRPr lang="en-US" dirty="0"/>
           </a:p>
         </p:txBody>
       </p:sp>
@@ -7029,7 +7002,13 @@
           <p:cNvGraphicFramePr>
             <a:graphicFrameLocks noGrp="1"/>
           </p:cNvGraphicFramePr>
-          <p:nvPr/>
+          <p:nvPr>
+            <p:extLst>
+              <p:ext uri="{D42A27DB-BD31-4B8C-83A1-F6EECF244321}">
+                <p14:modId xmlns:p14="http://schemas.microsoft.com/office/powerpoint/2010/main" val="3524035056"/>
+              </p:ext>
+            </p:extLst>
+          </p:nvPr>
         </p:nvGraphicFramePr>
         <p:xfrm>
           <a:off x="320040" y="1572768"/>
@@ -8458,7 +8437,7 @@
                           <a:ea typeface="Calibri" pitchFamily="34" charset="-122"/>
                           <a:cs typeface="Calibri" pitchFamily="34" charset="-120"/>
                         </a:rPr>
-                        <a:t>SAGA (tuned) ★</a:t>
+                        <a:t>SAGA (tuned)</a:t>
                       </a:r>
                       <a:endParaRPr lang="en-US" sz="1300" dirty="0">
                         <a:latin typeface="Calibri" charset="0"/>
@@ -9719,16 +9698,15 @@
                 <a:ea typeface="Calibri" pitchFamily="34" charset="-122"/>
                 <a:cs typeface="Calibri" pitchFamily="34" charset="-120"/>
               </a:rPr>
-              <a:t>SVRG std = 9×10⁻⁶ vs SGD std = 1.3×10⁻³</a:t>
-            </a:r>
-            <a:endParaRPr lang="en-US" sz="1200" dirty="0"/>
+              <a:t>SVRG std = 9×10⁻⁶ </a:t>
+            </a:r>
           </a:p>
           <a:p>
             <a:pPr marL="0" indent="0" algn="ctr">
               <a:buNone/>
             </a:pPr>
             <a:r>
-              <a:rPr lang="en-US" sz="1200" i="1" dirty="0">
+              <a:rPr lang="en-US" sz="1200" dirty="0">
                 <a:solidFill>
                   <a:srgbClr val="64748B"/>
                 </a:solidFill>
@@ -9736,7 +9714,56 @@
                 <a:ea typeface="Calibri" pitchFamily="34" charset="-122"/>
                 <a:cs typeface="Calibri" pitchFamily="34" charset="-120"/>
               </a:rPr>
-              <a:t>Variance reduction = variance-stable training</a:t>
+              <a:t>vs</a:t>
+            </a:r>
+          </a:p>
+          <a:p>
+            <a:pPr marL="0" indent="0" algn="ctr">
+              <a:buNone/>
+            </a:pPr>
+            <a:r>
+              <a:rPr lang="en-US" sz="1200" dirty="0">
+                <a:solidFill>
+                  <a:srgbClr val="64748B"/>
+                </a:solidFill>
+                <a:latin typeface="Calibri" pitchFamily="34" charset="0"/>
+                <a:ea typeface="Calibri" pitchFamily="34" charset="-122"/>
+                <a:cs typeface="Calibri" pitchFamily="34" charset="-120"/>
+              </a:rPr>
+              <a:t>SGD std = 1.3×10⁻³</a:t>
+            </a:r>
+            <a:endParaRPr lang="en-US" sz="1200" dirty="0"/>
+          </a:p>
+          <a:p>
+            <a:pPr marL="0" indent="0" algn="ctr">
+              <a:buNone/>
+            </a:pPr>
+            <a:r>
+              <a:rPr lang="en-US" sz="1200" i="1" dirty="0">
+                <a:solidFill>
+                  <a:srgbClr val="64748B"/>
+                </a:solidFill>
+                <a:latin typeface="Calibri" pitchFamily="34" charset="0"/>
+                <a:ea typeface="Calibri" pitchFamily="34" charset="-122"/>
+                <a:cs typeface="Calibri" pitchFamily="34" charset="-120"/>
+              </a:rPr>
+              <a:t>Variance reduction </a:t>
+            </a:r>
+          </a:p>
+          <a:p>
+            <a:pPr marL="0" indent="0" algn="ctr">
+              <a:buNone/>
+            </a:pPr>
+            <a:r>
+              <a:rPr lang="en-US" sz="1200" i="1" dirty="0">
+                <a:solidFill>
+                  <a:srgbClr val="64748B"/>
+                </a:solidFill>
+                <a:latin typeface="Calibri" pitchFamily="34" charset="0"/>
+                <a:ea typeface="Calibri" pitchFamily="34" charset="-122"/>
+                <a:cs typeface="Calibri" pitchFamily="34" charset="-120"/>
+              </a:rPr>
+              <a:t>= variance-stable training</a:t>
             </a:r>
             <a:endParaRPr lang="en-US" sz="1200" dirty="0"/>
           </a:p>

</xml_diff>